<commit_message>
docs(pptx): update slide 11 with completed multi-signal AI Stylist and optimize request timeout
</commit_message>
<xml_diff>
--- a/DoAnTotNghiep_NB_3DTryOn.pptx
+++ b/DoAnTotNghiep_NB_3DTryOn.pptx
@@ -4199,7 +4199,7 @@
               </a:defRPr>
             </a:pPr>
             <a:r>
-              <a:t>Tích Hợp Camera Realtime (AI Try-On)</a:t>
+              <a:t>Thử Đồ Qua Camera Realtime (Generative AI Try-On)</a:t>
             </a:r>
           </a:p>
           <a:p>
@@ -4214,7 +4214,7 @@
               </a:defRPr>
             </a:pPr>
             <a:r>
-              <a:t>LIVE WEBCAM AR/AI</a:t>
+              <a:t>FUTURE AR EXTENSION</a:t>
             </a:r>
           </a:p>
           <a:p>
@@ -4339,7 +4339,7 @@
               </a:defRPr>
             </a:pPr>
             <a:r>
-              <a:t>Trợ Lý AI Stylist Cá Nhân Hóa</a:t>
+              <a:t>Trợ Lý AI Stylist &amp; Combo Mua Sắm Cá Nhân Hóa Đa Chiều (Đã hoàn thiện)</a:t>
             </a:r>
           </a:p>
           <a:p>
@@ -4354,7 +4354,7 @@
               </a:defRPr>
             </a:pPr>
             <a:r>
-              <a:t>AI STYLIST RECOMMENDATION</a:t>
+              <a:t>COMPLETED MULTI-SIGNAL AI ENGINE</a:t>
             </a:r>
           </a:p>
           <a:p>

</xml_diff>